<commit_message>
Replace Part 03 chapter divider: rename + Feishu QR code.
Swap 战略跃迁与证据验证 for 系统筛选与方向收敛, drop the raw Feishu URL,
and encode the corpus table link as a scannable QR with short source note.

Co-authored-by: bobskywalker1023 <bobskywalker1023@gmail.com>
</commit_message>
<xml_diff>
--- a/mfk-slides/MFK_LVMH_品牌全案_主汇报.pptx
+++ b/mfk-slides/MFK_LVMH_品牌全案_主汇报.pptx
@@ -33,6 +33,7 @@
     <p:sldId id="281" r:id="rId32"/>
     <p:sldId id="282" r:id="rId33"/>
     <p:sldId id="283" r:id="rId34"/>
+    <p:sldId id="284" r:id="rId35"/>
   </p:sldIdLst>
   <p:sldSz cx="12192000" cy="6858000" type="screen4x3"/>
   <p:notesSz cx="6858000" cy="9144000"/>
@@ -3946,6 +3947,48 @@
 </file>
 
 <file path=ppt/slides/slide28.xml><?xml version="1.0" encoding="utf-8"?>
+<p:sld xmlns:a="http://schemas.openxmlformats.org/drawingml/2006/main" xmlns:p="http://schemas.openxmlformats.org/presentationml/2006/main" xmlns:r="http://schemas.openxmlformats.org/officeDocument/2006/relationships">
+  <p:cSld>
+    <p:spTree>
+      <p:nvGrpSpPr>
+        <p:cNvPr id="1" name=""/>
+        <p:cNvGrpSpPr/>
+        <p:nvPr/>
+      </p:nvGrpSpPr>
+      <p:grpSpPr/>
+      <p:pic>
+        <p:nvPicPr>
+          <p:cNvPr id="2" name="Picture 1" descr="_tmp_slide.jpg"/>
+          <p:cNvPicPr>
+            <a:picLocks noChangeAspect="1"/>
+          </p:cNvPicPr>
+          <p:nvPr/>
+        </p:nvPicPr>
+        <p:blipFill>
+          <a:blip r:embed="rId2"/>
+          <a:stretch>
+            <a:fillRect/>
+          </a:stretch>
+        </p:blipFill>
+        <p:spPr>
+          <a:xfrm>
+            <a:off x="0" y="0"/>
+            <a:ext cx="12192000" cy="6858000"/>
+          </a:xfrm>
+          <a:prstGeom prst="rect">
+            <a:avLst/>
+          </a:prstGeom>
+        </p:spPr>
+      </p:pic>
+    </p:spTree>
+  </p:cSld>
+  <p:clrMapOvr>
+    <a:masterClrMapping/>
+  </p:clrMapOvr>
+</p:sld>
+</file>
+
+<file path=ppt/slides/slide29.xml><?xml version="1.0" encoding="utf-8"?>
 <p:sld xmlns:a="http://schemas.openxmlformats.org/drawingml/2006/main" xmlns:p="http://schemas.openxmlformats.org/presentationml/2006/main" xmlns:r="http://schemas.openxmlformats.org/officeDocument/2006/relationships">
   <p:cSld>
     <p:spTree>

</xml_diff>

<commit_message>
Add aesthetic prophecy slide after TOC for competition fit.
Keep page-2 lexicon lock unchanged; insert a prophecy narrative that
states 精准的感性 as the next luxury aesthetic and chains trend →
positioning → wardrobe → journey → 90-day validation.

Co-authored-by: bobskywalker1023 <bobskywalker1023@gmail.com>
</commit_message>
<xml_diff>
--- a/mfk-slides/MFK_LVMH_品牌全案_主汇报.pptx
+++ b/mfk-slides/MFK_LVMH_品牌全案_主汇报.pptx
@@ -34,6 +34,7 @@
     <p:sldId id="282" r:id="rId33"/>
     <p:sldId id="283" r:id="rId34"/>
     <p:sldId id="284" r:id="rId35"/>
+    <p:sldId id="285" r:id="rId36"/>
   </p:sldIdLst>
   <p:sldSz cx="12192000" cy="6858000" type="screen4x3"/>
   <p:notesSz cx="6858000" cy="9144000"/>
@@ -4031,6 +4032,48 @@
 </file>
 
 <file path=ppt/slides/slide3.xml><?xml version="1.0" encoding="utf-8"?>
+<p:sld xmlns:a="http://schemas.openxmlformats.org/drawingml/2006/main" xmlns:p="http://schemas.openxmlformats.org/presentationml/2006/main" xmlns:r="http://schemas.openxmlformats.org/officeDocument/2006/relationships">
+  <p:cSld>
+    <p:spTree>
+      <p:nvGrpSpPr>
+        <p:cNvPr id="1" name=""/>
+        <p:cNvGrpSpPr/>
+        <p:nvPr/>
+      </p:nvGrpSpPr>
+      <p:grpSpPr/>
+      <p:pic>
+        <p:nvPicPr>
+          <p:cNvPr id="2" name="Picture 1" descr="_tmp_slide.jpg"/>
+          <p:cNvPicPr>
+            <a:picLocks noChangeAspect="1"/>
+          </p:cNvPicPr>
+          <p:nvPr/>
+        </p:nvPicPr>
+        <p:blipFill>
+          <a:blip r:embed="rId2"/>
+          <a:stretch>
+            <a:fillRect/>
+          </a:stretch>
+        </p:blipFill>
+        <p:spPr>
+          <a:xfrm>
+            <a:off x="0" y="0"/>
+            <a:ext cx="12192000" cy="6858000"/>
+          </a:xfrm>
+          <a:prstGeom prst="rect">
+            <a:avLst/>
+          </a:prstGeom>
+        </p:spPr>
+      </p:pic>
+    </p:spTree>
+  </p:cSld>
+  <p:clrMapOvr>
+    <a:masterClrMapping/>
+  </p:clrMapOvr>
+</p:sld>
+</file>
+
+<file path=ppt/slides/slide30.xml><?xml version="1.0" encoding="utf-8"?>
 <p:sld xmlns:a="http://schemas.openxmlformats.org/drawingml/2006/main" xmlns:p="http://schemas.openxmlformats.org/presentationml/2006/main" xmlns:r="http://schemas.openxmlformats.org/officeDocument/2006/relationships">
   <p:cSld>
     <p:spTree>

</xml_diff>